<commit_message>
Apply fact-audit corrections (Maldros Interview Tasks 23 and 33)
</commit_message>
<xml_diff>
--- a/case-study/maldros_case_study_deck.pptx
+++ b/case-study/maldros_case_study_deck.pptx
@@ -512,7 +512,7 @@
           <a:p>
             <a:r>
               <a:rPr lang="en-US" dirty="0"/>
-              <a:t>Portfolio case study for the Maldros system. Maturity states are labeled throughout: design-complete, validated via simulation, production-deployed (none). The 288.9s runtime is the least interesting result — governance held (94.6% citation coverage on the released report, three L1 vetoes, no auto-approve) is the differentiator.</a:t>
+              <a:t>Portfolio case study for the Maldros system. Maturity states are labeled throughout: design-complete, validated via simulation, production-deployed (none). The 288.9s runtime (run 6cf9b15c) is the least interesting result. The differentiator is the governance on the report approved at the Confirmation Gate: 97.9% citation coverage (1b4f50b2), all five L1 checks, no auto-approve.</a:t>
             </a:r>
             <a:endParaRPr lang="en-US" dirty="0"/>
           </a:p>
@@ -776,7 +776,7 @@
           <a:p>
             <a:r>
               <a:rPr lang="en-US" dirty="0"/>
-              <a:t>L1 executive summary. The four KPIs validate the finding. Amber focal = 94.6% citation coverage, the governance number. Nothing here is live production impact.</a:t>
+              <a:t>L1 executive summary. The four KPIs validate the finding. Amber focal = 97.9% citation coverage, the governance number. Nothing here is live production impact.</a:t>
             </a:r>
             <a:endParaRPr lang="en-US" dirty="0"/>
           </a:p>
@@ -1888,7 +1888,7 @@
                 <a:ea typeface="Calibri" pitchFamily="34" charset="-122"/>
                 <a:cs typeface="Calibri" pitchFamily="34" charset="-120"/>
               </a:rPr>
-              <a:t>Maldros ran a full analytics investigation — from a raw business question to an executive briefing — autonomously in </a:t>
+              <a:t>Maldros ran a full analytics investigation — from a raw business question to an executive briefing — autonomously in 288.9 seconds. Governance was never traded for that speed.</a:t>
             </a:r>
             <a:pPr algn="l" indent="0" marL="0">
               <a:lnSpc>
@@ -1905,7 +1905,7 @@
                 <a:ea typeface="Calibri" pitchFamily="34" charset="-122"/>
                 <a:cs typeface="Calibri" pitchFamily="34" charset="-120"/>
               </a:rPr>
-              <a:t>288.9 seconds</a:t>
+              <a:t/>
             </a:r>
             <a:pPr algn="l" indent="0" marL="0">
               <a:lnSpc>
@@ -1922,7 +1922,7 @@
                 <a:ea typeface="Calibri" pitchFamily="34" charset="-122"/>
                 <a:cs typeface="Calibri" pitchFamily="34" charset="-120"/>
               </a:rPr>
-              <a:t>, and the governance held the whole way.</a:t>
+              <a:t/>
             </a:r>
             <a:endParaRPr lang="en-US" sz="1900" dirty="0"/>
           </a:p>
@@ -3740,7 +3740,7 @@
                 <a:ea typeface="Calibri" pitchFamily="34" charset="-122"/>
                 <a:cs typeface="Calibri" pitchFamily="34" charset="-120"/>
               </a:rPr>
-              <a:t>94.6%</a:t>
+              <a:t>97.9%</a:t>
             </a:r>
             <a:endParaRPr lang="en-US" sz="3000" dirty="0"/>
           </a:p>
@@ -3828,7 +3828,7 @@
                 <a:ea typeface="Calibri" pitchFamily="34" charset="-122"/>
                 <a:cs typeface="Calibri" pitchFamily="34" charset="-120"/>
               </a:rPr>
-              <a:t>88 of 93 claims cited; enforced by veto</a:t>
+              <a:t>47 of 48 claims cited; enforced by veto</a:t>
             </a:r>
             <a:endParaRPr lang="en-US" sz="860" dirty="0"/>
           </a:p>
@@ -4189,7 +4189,7 @@
                 <a:ea typeface="Calibri" pitchFamily="34" charset="-122"/>
                 <a:cs typeface="Calibri" pitchFamily="34" charset="-120"/>
               </a:rPr>
-              <a:t>Source: case study Topic 1 · Phase 1 investigation, Discovery Report 84c4e728 · validated via simulation.</a:t>
+              <a:t>Source: case study Topic 1 · Phase 1 investigation · runtime from run 6cf9b15c, whose draft the L1 gate blocked; coverage from the approved report 1b4f50b2, Mode B f3d5a232 · validated via simulation.</a:t>
             </a:r>
             <a:endParaRPr lang="en-US" sz="950" dirty="0"/>
           </a:p>
@@ -4415,7 +4415,7 @@
                 <a:ea typeface="Calibri" pitchFamily="34" charset="-122"/>
                 <a:cs typeface="Calibri" pitchFamily="34" charset="-120"/>
               </a:rPr>
-              <a:t>Source: Phase 1 investigation · Discovery Report 84c4e728 · synthetic dataset (750K api_events, 18-month horizon) · validated via simulation.</a:t>
+              <a:t>Source: Phase 1 investigation · Discovery Report 1b4f50b2, run ff0b6f70 · synthetic dataset (750K api_events, 18-month horizon) · validated via simulation.</a:t>
             </a:r>
             <a:endParaRPr lang="en-US" sz="950" dirty="0"/>
           </a:p>
@@ -5201,7 +5201,7 @@
                 <a:ea typeface="Calibri" pitchFamily="34" charset="-122"/>
                 <a:cs typeface="Calibri" pitchFamily="34" charset="-120"/>
               </a:rPr>
-              <a:t>Three deterministic Storyteller L1 vetoes — causal-language, citation coverage, and omission audit — block a draft before it can ship. In Phase 1 the released report reached 94.6% citation coverage (88 of 93 claims); 14 of 18 development runs were blocked first.</a:t>
+              <a:t>Three deterministic Storyteller L1 vetoes — causal-language, citation coverage, and omission audit — block a draft before it can ship. In Phase 1 the report approved at the Confirmation Gate reached 97.9% citation coverage (47 of 48 claims) and cleared five L1 checks; 14 of 18 development runs were blocked first.</a:t>
             </a:r>
             <a:endParaRPr lang="en-US" sz="1350" dirty="0"/>
           </a:p>
@@ -7819,7 +7819,7 @@
                           <a:ea typeface="Calibri" pitchFamily="34" charset="-122"/>
                           <a:cs typeface="Calibri" pitchFamily="34" charset="-120"/>
                         </a:rPr>
-                        <a:t>100% correct Mode A / B (89 / 86); 73.6s, no scaffolding</a:t>
+                        <a:t>100% routing coverage; Mode A / B 89 / 86, default to Mode A (167 emitted + 8 schema); no scaffolding</a:t>
                       </a:r>
                       <a:endParaRPr lang="en-US" sz="1150" dirty="0">
                         <a:latin typeface="Calibri" charset="0"/>

</xml_diff>